<commit_message>
Update dashboard, README and deck
Co-Authored-By: Claude Sonnet 5.5 <noreply@anthropic.com>
</commit_message>
<xml_diff>
--- a/docs/presentation/knightai_ed_surge.pptx
+++ b/docs/presentation/knightai_ed_surge.pptx
@@ -111,27 +111,27 @@
   <p:extLst>
     <p:ext uri="{521415D9-36F7-43E2-AB2F-B90AF26B5E84}">
       <p14:sectionLst xmlns:p14="http://schemas.microsoft.com/office/powerpoint/2010/main">
-        <p14:section name="Problem" id="{a35ea84f-60ff-bcc6-cf4e-b9816214a141}">
+        <p14:section name="Problem" id="{5444d206-aa7e-3661-d390-9880e6199f6a}">
           <p14:sldIdLst>
             <p14:sldId id="256"/>
           </p14:sldIdLst>
         </p14:section>
-        <p14:section name="Solution" id="{f677e264-b957-f617-7553-2fe314508ea0}">
+        <p14:section name="Solution" id="{543c6791-fc9c-8811-be38-e290145f7cbb}">
           <p14:sldIdLst>
             <p14:sldId id="257"/>
           </p14:sldIdLst>
         </p14:section>
-        <p14:section name="Results" id="{ca9c7b6c-d920-6116-79e6-317118a8baa2}">
+        <p14:section name="Results" id="{99f58cca-d425-1107-3fb4-df978543fca1}">
           <p14:sldIdLst>
             <p14:sldId id="258"/>
           </p14:sldIdLst>
         </p14:section>
-        <p14:section name="Roadmap" id="{daa93436-ccaf-2224-9403-3bb9b670da2a}">
+        <p14:section name="Roadmap" id="{a5b93204-ee61-a6b0-c009-0a86135ebda7}">
           <p14:sldIdLst>
             <p14:sldId id="259"/>
           </p14:sldIdLst>
         </p14:section>
-        <p14:section name="Limits and team" id="{a654db2e-d0f8-9ab4-eaa2-644f65766dc9}">
+        <p14:section name="Limits and team" id="{d0d3b284-423c-1f00-0900-a9b00462432b}">
           <p14:sldIdLst>
             <p14:sldId id="260"/>
           </p14:sldIdLst>
@@ -540,7 +540,7 @@
           <a:p>
             <a:r>
               <a:rPr lang="en-US" dirty="0"/>
-              <a:t>Every summer, emergency departments plan for an ordinary day, and then a heatwave arrives. In our simulated reference department, built from the CDC's NHAMCS 2022 survey, a normal day sees 13.8 percent of urgent patients late. On a heatwave day that nearly doubles, to 26.7 percent. Patients who give up and leave unseen rise from 1.9 to 6.8 percent, and beds peak at 96 percent. Hospitals rarely know in advance where they will break first. PulseOps is built to answer that question before the surge arrives.</a:t>
+              <a:t>Every summer, emergency departments plan for an ordinary day, and then a heatwave arrives. In our simulated reference department, built from the CDC's NHAMCS 2022 survey, a normal day sees 13.8 percent of urgent patients late. On a heatwave day that nearly doubles, to 26.7 percent. Patients who give up and leave unseen rise from 1.9 to 6.8 percent, and beds peak at 96 percent. Hospitals rarely know in advance where they will break first. KnightAI is built to answer that question before the surge arrives.</a:t>
             </a:r>
             <a:endParaRPr lang="en-US" dirty="0"/>
           </a:p>
@@ -628,7 +628,7 @@
           <a:p>
             <a:r>
               <a:rPr lang="en-US" dirty="0"/>
-              <a:t>PulseOps starts from real patient patterns in the CDC's NHAMCS 2022 survey: when people arrive, how urgent they are, and how long care takes. A calibrated simulator replays the department event by event. Then we search 78 plans, such as an extra clinician or fast track, on the same 50 simulated days, and recommend one only when its 95 percent range clearly beats doing nothing. On the heatwave, that lifts urgent patients seen on time from 73 to 87 percent. An early-warning model scores the next four hours.</a:t>
+              <a:t>KnightAI starts from real patient patterns in the CDC's NHAMCS 2022 survey: when people arrive, how urgent they are, and how long care takes. A calibrated simulator replays the department event by event. Then we search 78 plans, such as an extra clinician or fast track, on the same 50 simulated days, and recommend one only when its 95 percent range clearly beats doing nothing. On the heatwave, that lifts urgent patients seen on time from 73 to 87 percent. An early-warning model scores the next four hours.</a:t>
             </a:r>
             <a:endParaRPr lang="en-US" dirty="0"/>
           </a:p>
@@ -892,7 +892,7 @@
           <a:p>
             <a:r>
               <a:rPr lang="en-US" dirty="0"/>
-              <a:t>We want to be clear about what this is. PulseOps is a simulation, not validated on a real hospital, built on a national survey sample rather than one emergency department. Our biggest open gap: simulated urgent patients wait a median 5.1 minutes, real ones 15.0. We show that number instead of hiding it. Next, we draw boarding and patience from the data, calibrate every hospital size and test on a partner hospital's records. We are Team KnightAI. Thank you.</a:t>
+              <a:t>We want to be clear about what this is. KnightAI is a simulation, not validated on a real hospital, built on a national survey sample rather than one emergency department. Our biggest open gap: simulated urgent patients wait a median 5.1 minutes, real ones 15.0. We show that number instead of hiding it. Next, we draw boarding and patience from the data, calibrate every hospital size and test on a partner hospital's records. We are Team KnightAI. Thank you.</a:t>
             </a:r>
             <a:endParaRPr lang="en-US" dirty="0"/>
           </a:p>
@@ -1096,7 +1096,7 @@
                   <a:schemeClr val="tx2"/>
                 </a:solidFill>
               </a:rPr>
-              <a:t>KnightAI   ·   PulseOps — ED Surge Simulator   ·   IBM Z Datathon 2026</a:t>
+              <a:t>KnightAI — ED Surge Simulator   ·   IBM Z Datathon 2026</a:t>
             </a:r>
             <a:endParaRPr lang="en-US" sz="1200" dirty="0"/>
           </a:p>
@@ -1527,7 +1527,7 @@
                   <a:schemeClr val="accent1"/>
                 </a:solidFill>
               </a:rPr>
-              <a:t>PULSEOPS — ED SURGE SIMULATOR   ·   THE PROBLEM</a:t>
+              <a:t>KNIGHTAI — ED SURGE SIMULATOR   ·   THE PROBLEM</a:t>
             </a:r>
             <a:endParaRPr lang="en-US" sz="1400" dirty="0"/>
           </a:p>
@@ -2122,7 +2122,7 @@
                   <a:schemeClr val="tx1"/>
                 </a:solidFill>
               </a:rPr>
-              <a:t>PulseOps tests every fix before the surge hits</a:t>
+              <a:t>KnightAI tests every fix before the surge hits</a:t>
             </a:r>
             <a:endParaRPr lang="en-US" sz="3200" dirty="0"/>
           </a:p>
@@ -2731,7 +2731,7 @@
       </p:sp>
       <p:pic>
         <p:nvPicPr>
-          <p:cNvPr id="23" name="Image 0" descr="PulseOps dashboard on a simulated heatwave day">    </p:cNvPr>
+          <p:cNvPr id="23" name="Image 0" descr="KnightAI dashboard on a simulated heatwave day">    </p:cNvPr>
           <p:cNvPicPr>
             <a:picLocks noChangeAspect="1"/>
           </p:cNvPicPr>
@@ -2790,7 +2790,7 @@
                   <a:srgbClr val="6B7280"/>
                 </a:solidFill>
               </a:rPr>
-              <a:t>The PulseOps dashboard on a simulated heatwave day</a:t>
+              <a:t>The KnightAI dashboard on a simulated heatwave day</a:t>
             </a:r>
             <a:endParaRPr lang="en-US" sz="1400" dirty="0"/>
           </a:p>
@@ -7148,9 +7148,9 @@
 </file>
 
 <file path=ppt/theme/theme1.xml><?xml version="1.0" encoding="utf-8"?>
-<a:theme xmlns:a="http://schemas.openxmlformats.org/drawingml/2006/main" name="PulseOps">
+<a:theme xmlns:a="http://schemas.openxmlformats.org/drawingml/2006/main" name="KnightAI">
   <a:themeElements>
-    <a:clrScheme name="PulseOps">
+    <a:clrScheme name="KnightAI">
       <a:dk1>
         <a:srgbClr val="111827"/>
       </a:dk1>
@@ -7188,7 +7188,7 @@
         <a:srgbClr val="5B3E96"/>
       </a:folHlink>
     </a:clrScheme>
-    <a:fontScheme name="PulseOps">
+    <a:fontScheme name="KnightAI">
       <a:majorFont>
         <a:latin typeface="Calibri"/>
         <a:ea typeface=""/>

</xml_diff>